<commit_message>
Restore eval mode correctly; derive the long-sentence claim from data
evaluate_perplexity assumed it was always called from training and forced
train() on exit; it now restores whatever mode it found. Harmless today
(dropout is 0, per the paper) but wrong if dropout is ever enabled.

The end-term slide no longer asserts that BLEU falls away on long sentences;
it reads the measured length curve and states what actually happened.

Co-Authored-By: Claude Opus 5 <noreply@anthropic.com>
</commit_message>
<xml_diff>
--- a/slides/EE5180_midterm_slides.pptx
+++ b/slides/EE5180_midterm_slides.pptx
@@ -3150,8 +3150,8 @@
         </p:nvSpPr>
         <p:spPr>
           <a:xfrm>
-            <a:off x="548640" y="2560320"/>
-            <a:ext cx="10515600" cy="822960"/>
+            <a:off x="548640" y="2514600"/>
+            <a:ext cx="10972800" cy="1051560"/>
           </a:xfrm>
           <a:prstGeom prst="rect">
             <a:avLst/>
@@ -3167,7 +3167,7 @@
               <a:buNone/>
             </a:pPr>
             <a:r>
-              <a:rPr lang="en-US" sz="1600" dirty="0">
+              <a:rPr lang="en-US" sz="1500" dirty="0">
                 <a:solidFill>
                   <a:srgbClr val="CADCFC"/>
                 </a:solidFill>
@@ -3175,9 +3175,9 @@
                 <a:ea typeface="Calibri" pitchFamily="34" charset="-122"/>
                 <a:cs typeface="Calibri" pitchFamily="34" charset="-120"/>
               </a:rPr>
-              <a:t>A twelve-word sentence and a fifty-word sentence are compressed into the same 2048 numbers before a single target word is emitted. That is the bottleneck — and it is why our BLEU falls away on long sentences.</a:t>
-            </a:r>
-            <a:endParaRPr lang="en-US" sz="1600" dirty="0"/>
+              <a:t>A twelve-word sentence and a fifty-word sentence are compressed into the same 2048 numbers before a single target word is emitted. That is the bottleneck. In our runs on Multi30k, reversed-model BLEU falls from 20.2 on 1-10-token sources to 7.9 on 21-30 — the paper, at full scale, reported no such degradation.</a:t>
+            </a:r>
+            <a:endParaRPr lang="en-US" sz="1500" dirty="0"/>
           </a:p>
         </p:txBody>
       </p:sp>

</xml_diff>

<commit_message>
Correct beam and long-sentence claims; bring docs up to date
The report and slides still said "beam 2 recovers 216% of the gain,
reproducing the paper's observation", and the verdict slide listed the beam
trend as reproduced -- both contradicted by the beam ablation. They now branch
on the measured ordering and state that the monotone beam gain does not
reproduce.

Adds a per-length-bucket table: reversal leads in every bucket, but both
models degrade on long sentences, so the paper's long-sentence robustness
(sec. 3.7) does not reproduce either. Framed as consistent with the
fixed-vector bottleneck rather than proof of it.

README gains a results section, the current file map, the two memory fixes
with measurements, and the beam-ablation / Colab steps. Adds a make
beam-ablation target, fixes stale test counts, and writes CSVs with LF.

Co-Authored-By: Claude Opus 5 <noreply@anthropic.com>
</commit_message>
<xml_diff>
--- a/slides/EE5180_midterm_slides.pptx
+++ b/slides/EE5180_midterm_slides.pptx
@@ -2146,7 +2146,7 @@
                 <a:ea typeface="Calibri" pitchFamily="34" charset="-122"/>
                 <a:cs typeface="Calibri" pitchFamily="34" charset="-120"/>
               </a:rPr>
-              <a:t>Correctness gates (pytest, ~12 s)</a:t>
+              <a:t>Correctness gates (23 tests, ~3 s)</a:t>
             </a:r>
             <a:endParaRPr lang="en-US" sz="1600" dirty="0"/>
           </a:p>
@@ -2700,11 +2700,11 @@
         <p:spPr>
           <a:xfrm>
             <a:off x="548640" y="1600200"/>
-            <a:ext cx="5349240" cy="3566160"/>
+            <a:ext cx="5349240" cy="2788920"/>
           </a:xfrm>
           <a:prstGeom prst="roundRect">
             <a:avLst>
-              <a:gd name="adj" fmla="val 2308"/>
+              <a:gd name="adj" fmla="val 2951"/>
             </a:avLst>
           </a:prstGeom>
           <a:solidFill>
@@ -2766,7 +2766,7 @@
         <p:spPr>
           <a:xfrm>
             <a:off x="777240" y="2240280"/>
-            <a:ext cx="4892040" cy="2743200"/>
+            <a:ext cx="4892040" cy="2011680"/>
           </a:xfrm>
           <a:prstGeom prst="rect">
             <a:avLst/>
@@ -2786,7 +2786,7 @@
               <a:buChar char="•"/>
             </a:pPr>
             <a:r>
-              <a:rPr lang="en-US" sz="1400" dirty="0">
+              <a:rPr lang="en-US" sz="1350" dirty="0">
                 <a:solidFill>
                   <a:srgbClr val="3B4A7A"/>
                 </a:solidFill>
@@ -2794,9 +2794,9 @@
                 <a:ea typeface="Calibri" pitchFamily="34" charset="-122"/>
                 <a:cs typeface="Calibri" pitchFamily="34" charset="-120"/>
               </a:rPr>
-              <a:t>Reversing the source improves both BLEU and perplexity by a clear margin, under an otherwise identical setup.</a:t>
-            </a:r>
-            <a:endParaRPr lang="en-US" sz="1400" dirty="0"/>
+              <a:t>Reversal gains +2.71 BLEU and cuts test perplexity 25% (paper: +4.42, 19%) with nothing else changed.</a:t>
+            </a:r>
+            <a:endParaRPr lang="en-US" sz="1350" dirty="0"/>
           </a:p>
           <a:p>
             <a:pPr marL="342900" indent="-342900">
@@ -2807,7 +2807,7 @@
               <a:buChar char="•"/>
             </a:pPr>
             <a:r>
-              <a:rPr lang="en-US" sz="1400" dirty="0">
+              <a:rPr lang="en-US" sz="1350" dirty="0">
                 <a:solidFill>
                   <a:srgbClr val="3B4A7A"/>
                 </a:solidFill>
@@ -2815,9 +2815,9 @@
                 <a:ea typeface="Calibri" pitchFamily="34" charset="-122"/>
                 <a:cs typeface="Calibri" pitchFamily="34" charset="-120"/>
               </a:rPr>
-              <a:t>A beam of 2 captures most of the benefit of a beam of 12.</a:t>
-            </a:r>
-            <a:endParaRPr lang="en-US" sz="1400" dirty="0"/>
+              <a:t>The reversed model leads at every epoch and in every sentence-length bucket.</a:t>
+            </a:r>
+            <a:endParaRPr lang="en-US" sz="1350" dirty="0"/>
           </a:p>
           <a:p>
             <a:pPr marL="342900" indent="-342900">
@@ -2828,7 +2828,7 @@
               <a:buChar char="•"/>
             </a:pPr>
             <a:r>
-              <a:rPr lang="en-US" sz="1400" dirty="0">
+              <a:rPr lang="en-US" sz="1350" dirty="0">
                 <a:solidFill>
                   <a:srgbClr val="3B4A7A"/>
                 </a:solidFill>
@@ -2836,9 +2836,9 @@
                 <a:ea typeface="Calibri" pitchFamily="34" charset="-122"/>
                 <a:cs typeface="Calibri" pitchFamily="34" charset="-120"/>
               </a:rPr>
-              <a:t>The ordering of Table 1 rows 3 and 4 holds at our scale.</a:t>
-            </a:r>
-            <a:endParaRPr lang="en-US" sz="1400" dirty="0"/>
+              <a:t>Ensembling helps: 3 reversed seeds add +2.7 BLEU on Multi30k.</a:t>
+            </a:r>
+            <a:endParaRPr lang="en-US" sz="1350" dirty="0"/>
           </a:p>
         </p:txBody>
       </p:sp>
@@ -2851,11 +2851,11 @@
         <p:spPr>
           <a:xfrm>
             <a:off x="6400800" y="1600200"/>
-            <a:ext cx="5212080" cy="3566160"/>
+            <a:ext cx="5212080" cy="2788920"/>
           </a:xfrm>
           <a:prstGeom prst="roundRect">
             <a:avLst>
-              <a:gd name="adj" fmla="val 2308"/>
+              <a:gd name="adj" fmla="val 2951"/>
             </a:avLst>
           </a:prstGeom>
           <a:solidFill>
@@ -2902,7 +2902,7 @@
                 <a:ea typeface="Calibri" pitchFamily="34" charset="-122"/>
                 <a:cs typeface="Calibri" pitchFamily="34" charset="-120"/>
               </a:rPr>
-              <a:t>Not attempted</a:t>
+              <a:t>Did not reproduce</a:t>
             </a:r>
             <a:endParaRPr lang="en-US" sz="1600" dirty="0"/>
           </a:p>
@@ -2917,7 +2917,7 @@
         <p:spPr>
           <a:xfrm>
             <a:off x="6629400" y="2240280"/>
-            <a:ext cx="4754880" cy="2743200"/>
+            <a:ext cx="4754880" cy="2011680"/>
           </a:xfrm>
           <a:prstGeom prst="rect">
             <a:avLst/>
@@ -2937,7 +2937,7 @@
               <a:buChar char="•"/>
             </a:pPr>
             <a:r>
-              <a:rPr lang="en-US" sz="1400" dirty="0">
+              <a:rPr lang="en-US" sz="1350" dirty="0">
                 <a:solidFill>
                   <a:srgbClr val="3B4A7A"/>
                 </a:solidFill>
@@ -2945,9 +2945,9 @@
                 <a:ea typeface="Calibri" pitchFamily="34" charset="-122"/>
                 <a:cs typeface="Calibri" pitchFamily="34" charset="-120"/>
               </a:rPr>
-              <a:t>Absolute BLEU anywhere near 26–31.</a:t>
-            </a:r>
-            <a:endParaRPr lang="en-US" sz="1400" dirty="0"/>
+              <a:t>Monotone gains from a wider beam: BLEU peaks at beam 2, and length normalisation makes beam 12 worse.</a:t>
+            </a:r>
+            <a:endParaRPr lang="en-US" sz="1350" dirty="0"/>
           </a:p>
           <a:p>
             <a:pPr marL="342900" indent="-342900">
@@ -2958,7 +2958,7 @@
               <a:buChar char="•"/>
             </a:pPr>
             <a:r>
-              <a:rPr lang="en-US" sz="1400" dirty="0">
+              <a:rPr lang="en-US" sz="1350" dirty="0">
                 <a:solidFill>
                   <a:srgbClr val="3B4A7A"/>
                 </a:solidFill>
@@ -2966,9 +2966,9 @@
                 <a:ea typeface="Calibri" pitchFamily="34" charset="-122"/>
                 <a:cs typeface="Calibri" pitchFamily="34" charset="-120"/>
               </a:rPr>
-              <a:t>The 5-model ensemble rows of Table 1.</a:t>
-            </a:r>
-            <a:endParaRPr lang="en-US" sz="1400" dirty="0"/>
+              <a:t>Robustness on long sentences: both models degrade past 40 source tokens.</a:t>
+            </a:r>
+            <a:endParaRPr lang="en-US" sz="1350" dirty="0"/>
           </a:p>
           <a:p>
             <a:pPr marL="342900" indent="-342900">
@@ -2979,7 +2979,7 @@
               <a:buChar char="•"/>
             </a:pPr>
             <a:r>
-              <a:rPr lang="en-US" sz="1400" dirty="0">
+              <a:rPr lang="en-US" sz="1350" dirty="0">
                 <a:solidFill>
                   <a:srgbClr val="3B4A7A"/>
                 </a:solidFill>
@@ -2987,9 +2987,9 @@
                 <a:ea typeface="Calibri" pitchFamily="34" charset="-122"/>
                 <a:cs typeface="Calibri" pitchFamily="34" charset="-120"/>
               </a:rPr>
-              <a:t>The 1000-best SMT rescoring of Table 2.</a:t>
-            </a:r>
-            <a:endParaRPr lang="en-US" sz="1400" dirty="0"/>
+              <a:t>Absolute BLEU near 26–31 — 24× less data, and ~16% of output tokens are &lt;unk&gt;.</a:t>
+            </a:r>
+            <a:endParaRPr lang="en-US" sz="1350" dirty="0"/>
           </a:p>
         </p:txBody>
       </p:sp>
@@ -3001,7 +3001,7 @@
         </p:nvSpPr>
         <p:spPr>
           <a:xfrm>
-            <a:off x="548640" y="5349240"/>
+            <a:off x="548640" y="4663440"/>
             <a:ext cx="11064240" cy="548640"/>
           </a:xfrm>
           <a:prstGeom prst="rect">
@@ -3018,7 +3018,7 @@
               <a:buNone/>
             </a:pPr>
             <a:r>
-              <a:rPr lang="en-US" sz="1450" i="1" dirty="0">
+              <a:rPr lang="en-US" sz="1400" i="1" dirty="0">
                 <a:solidFill>
                   <a:srgbClr val="3B4A7A"/>
                 </a:solidFill>
@@ -3026,9 +3026,9 @@
                 <a:ea typeface="Calibri" pitchFamily="34" charset="-122"/>
                 <a:cs typeface="Calibri" pitchFamily="34" charset="-120"/>
               </a:rPr>
-              <a:t>These need the paper's data and compute. We say so, rather than presenting a smaller number as if it were comparable.</a:t>
-            </a:r>
-            <a:endParaRPr lang="en-US" sz="1450" dirty="0"/>
+              <a:t>Not attempted: the 5-model ensemble rows on WMT and Table 2's rescoring. We report the misses rather than hide them.</a:t>
+            </a:r>
+            <a:endParaRPr lang="en-US" sz="1400" dirty="0"/>
           </a:p>
         </p:txBody>
       </p:sp>
@@ -8487,7 +8487,7 @@
         <p:spPr>
           <a:xfrm>
             <a:off x="548640" y="4160520"/>
-            <a:ext cx="3566160" cy="1481328"/>
+            <a:ext cx="3502152" cy="1481328"/>
           </a:xfrm>
           <a:prstGeom prst="roundRect">
             <a:avLst>
@@ -8514,7 +8514,7 @@
         <p:spPr>
           <a:xfrm>
             <a:off x="548640" y="4306824"/>
-            <a:ext cx="3566160" cy="786384"/>
+            <a:ext cx="3502152" cy="786384"/>
           </a:xfrm>
           <a:prstGeom prst="rect">
             <a:avLst/>
@@ -8553,7 +8553,7 @@
         <p:spPr>
           <a:xfrm>
             <a:off x="658368" y="5102352"/>
-            <a:ext cx="3346704" cy="457200"/>
+            <a:ext cx="3282696" cy="457200"/>
           </a:xfrm>
           <a:prstGeom prst="rect">
             <a:avLst/>
@@ -8608,8 +8608,8 @@
         </p:nvSpPr>
         <p:spPr>
           <a:xfrm>
-            <a:off x="4434840" y="4160520"/>
-            <a:ext cx="3566160" cy="1481328"/>
+            <a:off x="4325112" y="4160520"/>
+            <a:ext cx="3502152" cy="1481328"/>
           </a:xfrm>
           <a:prstGeom prst="roundRect">
             <a:avLst>
@@ -8635,8 +8635,8 @@
         </p:nvSpPr>
         <p:spPr>
           <a:xfrm>
-            <a:off x="4434840" y="4306824"/>
-            <a:ext cx="3566160" cy="786384"/>
+            <a:off x="4325112" y="4306824"/>
+            <a:ext cx="3502152" cy="786384"/>
           </a:xfrm>
           <a:prstGeom prst="rect">
             <a:avLst/>
@@ -8674,8 +8674,8 @@
         </p:nvSpPr>
         <p:spPr>
           <a:xfrm>
-            <a:off x="4544568" y="5102352"/>
-            <a:ext cx="3346704" cy="457200"/>
+            <a:off x="4434840" y="5102352"/>
+            <a:ext cx="3282696" cy="457200"/>
           </a:xfrm>
           <a:prstGeom prst="rect">
             <a:avLst/>
@@ -8730,8 +8730,8 @@
         </p:nvSpPr>
         <p:spPr>
           <a:xfrm>
-            <a:off x="8321040" y="4160520"/>
-            <a:ext cx="3566160" cy="1481328"/>
+            <a:off x="8110728" y="4160520"/>
+            <a:ext cx="3502152" cy="1481328"/>
           </a:xfrm>
           <a:prstGeom prst="roundRect">
             <a:avLst>
@@ -8757,8 +8757,8 @@
         </p:nvSpPr>
         <p:spPr>
           <a:xfrm>
-            <a:off x="8321040" y="4306824"/>
-            <a:ext cx="3566160" cy="786384"/>
+            <a:off x="8110728" y="4306824"/>
+            <a:ext cx="3502152" cy="786384"/>
           </a:xfrm>
           <a:prstGeom prst="rect">
             <a:avLst/>
@@ -8796,8 +8796,8 @@
         </p:nvSpPr>
         <p:spPr>
           <a:xfrm>
-            <a:off x="8430768" y="5102352"/>
-            <a:ext cx="3346704" cy="457200"/>
+            <a:off x="8220456" y="5102352"/>
+            <a:ext cx="3282696" cy="457200"/>
           </a:xfrm>
           <a:prstGeom prst="rect">
             <a:avLst/>
@@ -9042,8 +9042,8 @@
         </p:nvSpPr>
         <p:spPr>
           <a:xfrm>
-            <a:off x="548640" y="4956048"/>
-            <a:ext cx="11064240" cy="685800"/>
+            <a:off x="548640" y="4919472"/>
+            <a:ext cx="11064240" cy="914400"/>
           </a:xfrm>
           <a:prstGeom prst="rect">
             <a:avLst/>
@@ -9059,7 +9059,7 @@
               <a:buNone/>
             </a:pPr>
             <a:r>
-              <a:rPr lang="en-US" sz="1400" dirty="0">
+              <a:rPr lang="en-US" sz="1350" dirty="0">
                 <a:solidFill>
                   <a:srgbClr val="3B4A7A"/>
                 </a:solidFill>
@@ -9067,9 +9067,9 @@
                 <a:ea typeface="Calibri" pitchFamily="34" charset="-122"/>
                 <a:cs typeface="Calibri" pitchFamily="34" charset="-120"/>
               </a:rPr>
-              <a:t>Beam 2 recovers 216% of the gain from beam 1 to beam 12 — reproducing the paper's observation that "a beam of size 2 provides most of the benefits of beam search".</a:t>
-            </a:r>
-            <a:endParaRPr lang="en-US" sz="1400" dirty="0"/>
+              <a:t>Beam: 6.41 → 6.82 → 6.60 BLEU. It peaks at beam 2, so the paper's monotone beam gain does NOT reproduce — a wider beam finds likelier but worse translations. Length: reversed leads in every bucket, but falls from 9.5 to 3.7 BLEU on the longest sentences.</a:t>
+            </a:r>
+            <a:endParaRPr lang="en-US" sz="1350" dirty="0"/>
           </a:p>
         </p:txBody>
       </p:sp>

</xml_diff>